<commit_message>
Corrige concordância e paralelismo na carta de apresentação
Na página e na versão em PPTX/PDF, que compartilham o mesmo texto:

- "uma escola e espaço de convivência dedicado ao skate e ao patins"
  vira "uma escola e um espaço de convivência dedicados ao skate e aos
  patins" — sujeito composto pede plural e "patins" é plural. Pelo mesmo
  motivo, "o skate e o patins são ferramentas" vira "os patins".
- A lista de possibilidades passa a ter os oito itens na mesma
  construção: o sujeito sai do primeiro item ("Uma marca pode estar
  presente na pista") e vira a frase que abre a lista, então todos
  começam por "Pode…" — e o último segue fechando com "Ou podemos…".

Na pág. 4 do PPTX os respiros da grade foram apertados um pouco para
abrir espaço para a frase de abertura sem passar do limite da folha.

Co-Authored-By: Claude Opus 5 <noreply@anthropic.com>
Claude-Session: https://claude.ai/code/session_014qcuMGFhfmtZUd17pAmMyN
</commit_message>
<xml_diff>
--- a/carta-de-apresentacao/carta-de-apresentacao-loop-skate-park.pptx
+++ b/carta-de-apresentacao/carta-de-apresentacao-loop-skate-park.pptx
@@ -1786,7 +1786,7 @@
                 <a:ea typeface="Barlow" pitchFamily="34" charset="-122"/>
                 <a:cs typeface="Barlow" pitchFamily="34" charset="-120"/>
               </a:rPr>
-              <a:t>, uma escola e espaço de convivência dedicado ao skate e ao patins, em Belo Horizonte.</a:t>
+              <a:t>, uma escola e um espaço de convivência dedicados ao skate e aos patins, em Belo Horizonte.</a:t>
             </a:r>
             <a:endParaRPr lang="en-US" sz="1300" dirty="0"/>
           </a:p>
@@ -2006,7 +2006,7 @@
                 <a:ea typeface="Barlow" pitchFamily="34" charset="-122"/>
                 <a:cs typeface="Barlow" pitchFamily="34" charset="-120"/>
               </a:rPr>
-              <a:t>Mais do que uma pista ou uma escola de esporte, queremos construir em Belo Horizonte um espaço onde esporte, cultura, educação, arte e convivência possam caminhar juntos. Acreditamos que o skate e o patins são ferramentas potentes para desenvolver autonomia, confiança, criatividade, respeito e senso de pertencimento.</a:t>
+              <a:t>Mais do que uma pista ou uma escola de esporte, queremos construir em Belo Horizonte um espaço onde esporte, cultura, educação, arte e convivência possam caminhar juntos. Acreditamos que o skate e os patins são ferramentas potentes para desenvolver autonomia, confiança, criatividade, respeito e senso de pertencimento.</a:t>
             </a:r>
             <a:endParaRPr lang="en-US" sz="1100" dirty="0"/>
           </a:p>
@@ -3383,14 +3383,56 @@
       </p:sp>
       <p:sp>
         <p:nvSpPr>
-          <p:cNvPr id="6" name="Shape 3"/>
-          <p:cNvSpPr/>
-          <p:nvPr/>
-        </p:nvSpPr>
-        <p:spPr>
-          <a:xfrm>
-            <a:off x="725932" y="2193086"/>
-            <a:ext cx="2941828" cy="555244"/>
+          <p:cNvPr id="6" name="Text 3"/>
+          <p:cNvSpPr/>
+          <p:nvPr/>
+        </p:nvSpPr>
+        <p:spPr>
+          <a:xfrm>
+            <a:off x="713232" y="2180386"/>
+            <a:ext cx="6135624" cy="270814"/>
+          </a:xfrm>
+          <a:prstGeom prst="rect">
+            <a:avLst/>
+          </a:prstGeom>
+          <a:noFill/>
+          <a:ln/>
+        </p:spPr>
+        <p:txBody>
+          <a:bodyPr wrap="square" lIns="0" tIns="0" rIns="0" bIns="0" rtlCol="0" anchor="t"/>
+          <a:lstStyle/>
+          <a:p>
+            <a:pPr indent="0" marL="0">
+              <a:lnSpc>
+                <a:spcPts val="1700"/>
+              </a:lnSpc>
+              <a:buNone/>
+            </a:pPr>
+            <a:r>
+              <a:rPr lang="en-US" sz="1100" dirty="0">
+                <a:solidFill>
+                  <a:srgbClr val="111111"/>
+                </a:solidFill>
+                <a:latin typeface="Barlow" pitchFamily="34" charset="0"/>
+                <a:ea typeface="Barlow" pitchFamily="34" charset="-122"/>
+                <a:cs typeface="Barlow" pitchFamily="34" charset="-120"/>
+              </a:rPr>
+              <a:t>Uma marca parceira pode caminhar com a gente de vários jeitos:</a:t>
+            </a:r>
+            <a:endParaRPr lang="en-US" sz="1100" dirty="0"/>
+          </a:p>
+        </p:txBody>
+      </p:sp>
+      <p:sp>
+        <p:nvSpPr>
+          <p:cNvPr id="7" name="Shape 4"/>
+          <p:cNvSpPr/>
+          <p:nvPr/>
+        </p:nvSpPr>
+        <p:spPr>
+          <a:xfrm>
+            <a:off x="725932" y="2651184"/>
+            <a:ext cx="2941828" cy="518668"/>
           </a:xfrm>
           <a:prstGeom prst="rect">
             <a:avLst/>
@@ -3408,13 +3450,13 @@
       </p:sp>
       <p:sp>
         <p:nvSpPr>
-          <p:cNvPr id="7" name="Shape 4"/>
-          <p:cNvSpPr/>
-          <p:nvPr/>
-        </p:nvSpPr>
-        <p:spPr>
-          <a:xfrm>
-            <a:off x="850392" y="2333548"/>
+          <p:cNvPr id="8" name="Shape 5"/>
+          <p:cNvSpPr/>
+          <p:nvPr/>
+        </p:nvSpPr>
+        <p:spPr>
+          <a:xfrm>
+            <a:off x="850392" y="2773358"/>
             <a:ext cx="274320" cy="274320"/>
           </a:xfrm>
           <a:prstGeom prst="roundRect">
@@ -3435,13 +3477,13 @@
       </p:sp>
       <p:sp>
         <p:nvSpPr>
-          <p:cNvPr id="8" name="Shape 5"/>
-          <p:cNvSpPr/>
-          <p:nvPr/>
-        </p:nvSpPr>
-        <p:spPr>
-          <a:xfrm>
-            <a:off x="918972" y="2466136"/>
+          <p:cNvPr id="9" name="Shape 6"/>
+          <p:cNvSpPr/>
+          <p:nvPr/>
+        </p:nvSpPr>
+        <p:spPr>
+          <a:xfrm>
+            <a:off x="918972" y="2905946"/>
             <a:ext cx="50292" cy="64008"/>
           </a:xfrm>
           <a:prstGeom prst="line">
@@ -3458,13 +3500,13 @@
       </p:sp>
       <p:sp>
         <p:nvSpPr>
-          <p:cNvPr id="9" name="Shape 6"/>
+          <p:cNvPr id="10" name="Shape 7"/>
           <p:cNvSpPr/>
           <p:nvPr/>
         </p:nvSpPr>
         <p:spPr>
           <a:xfrm flipV="1">
-            <a:off x="969264" y="2411272"/>
+            <a:off x="969264" y="2851082"/>
             <a:ext cx="91440" cy="118872"/>
           </a:xfrm>
           <a:prstGeom prst="line">
@@ -3481,14 +3523,14 @@
       </p:sp>
       <p:sp>
         <p:nvSpPr>
-          <p:cNvPr id="10" name="Text 7"/>
-          <p:cNvSpPr/>
-          <p:nvPr/>
-        </p:nvSpPr>
-        <p:spPr>
-          <a:xfrm>
-            <a:off x="1225296" y="2180386"/>
-            <a:ext cx="2327148" cy="580644"/>
+          <p:cNvPr id="11" name="Text 8"/>
+          <p:cNvSpPr/>
+          <p:nvPr/>
+        </p:nvSpPr>
+        <p:spPr>
+          <a:xfrm>
+            <a:off x="1225296" y="2638484"/>
+            <a:ext cx="2327148" cy="544068"/>
           </a:xfrm>
           <a:prstGeom prst="rect">
             <a:avLst/>
@@ -3515,7 +3557,7 @@
                 <a:ea typeface="Barlow" pitchFamily="34" charset="-122"/>
                 <a:cs typeface="Barlow" pitchFamily="34" charset="-120"/>
               </a:rPr>
-              <a:t>Uma marca pode estar presente na pista.</a:t>
+              <a:t>Pode estar presente na pista.</a:t>
             </a:r>
             <a:endParaRPr lang="en-US" sz="1000" dirty="0"/>
           </a:p>
@@ -3523,14 +3565,14 @@
       </p:sp>
       <p:sp>
         <p:nvSpPr>
-          <p:cNvPr id="11" name="Shape 8"/>
-          <p:cNvSpPr/>
-          <p:nvPr/>
-        </p:nvSpPr>
-        <p:spPr>
-          <a:xfrm>
-            <a:off x="3894328" y="2193086"/>
-            <a:ext cx="2941828" cy="555244"/>
+          <p:cNvPr id="12" name="Shape 9"/>
+          <p:cNvSpPr/>
+          <p:nvPr/>
+        </p:nvSpPr>
+        <p:spPr>
+          <a:xfrm>
+            <a:off x="3894328" y="2651184"/>
+            <a:ext cx="2941828" cy="518668"/>
           </a:xfrm>
           <a:prstGeom prst="rect">
             <a:avLst/>
@@ -3548,13 +3590,13 @@
       </p:sp>
       <p:sp>
         <p:nvSpPr>
-          <p:cNvPr id="12" name="Shape 9"/>
-          <p:cNvSpPr/>
-          <p:nvPr/>
-        </p:nvSpPr>
-        <p:spPr>
-          <a:xfrm>
-            <a:off x="4018788" y="2333548"/>
+          <p:cNvPr id="13" name="Shape 10"/>
+          <p:cNvSpPr/>
+          <p:nvPr/>
+        </p:nvSpPr>
+        <p:spPr>
+          <a:xfrm>
+            <a:off x="4018788" y="2773358"/>
             <a:ext cx="274320" cy="274320"/>
           </a:xfrm>
           <a:prstGeom prst="roundRect">
@@ -3575,13 +3617,13 @@
       </p:sp>
       <p:sp>
         <p:nvSpPr>
-          <p:cNvPr id="13" name="Shape 10"/>
-          <p:cNvSpPr/>
-          <p:nvPr/>
-        </p:nvSpPr>
-        <p:spPr>
-          <a:xfrm>
-            <a:off x="4087368" y="2466136"/>
+          <p:cNvPr id="14" name="Shape 11"/>
+          <p:cNvSpPr/>
+          <p:nvPr/>
+        </p:nvSpPr>
+        <p:spPr>
+          <a:xfrm>
+            <a:off x="4087368" y="2905946"/>
             <a:ext cx="50292" cy="64008"/>
           </a:xfrm>
           <a:prstGeom prst="line">
@@ -3598,13 +3640,13 @@
       </p:sp>
       <p:sp>
         <p:nvSpPr>
-          <p:cNvPr id="14" name="Shape 11"/>
+          <p:cNvPr id="15" name="Shape 12"/>
           <p:cNvSpPr/>
           <p:nvPr/>
         </p:nvSpPr>
         <p:spPr>
           <a:xfrm flipV="1">
-            <a:off x="4137660" y="2411272"/>
+            <a:off x="4137660" y="2851082"/>
             <a:ext cx="91440" cy="118872"/>
           </a:xfrm>
           <a:prstGeom prst="line">
@@ -3621,14 +3663,14 @@
       </p:sp>
       <p:sp>
         <p:nvSpPr>
-          <p:cNvPr id="15" name="Text 12"/>
-          <p:cNvSpPr/>
-          <p:nvPr/>
-        </p:nvSpPr>
-        <p:spPr>
-          <a:xfrm>
-            <a:off x="4393692" y="2180386"/>
-            <a:ext cx="2327148" cy="580644"/>
+          <p:cNvPr id="16" name="Text 13"/>
+          <p:cNvSpPr/>
+          <p:nvPr/>
+        </p:nvSpPr>
+        <p:spPr>
+          <a:xfrm>
+            <a:off x="4393692" y="2638484"/>
+            <a:ext cx="2327148" cy="544068"/>
           </a:xfrm>
           <a:prstGeom prst="rect">
             <a:avLst/>
@@ -3663,14 +3705,14 @@
       </p:sp>
       <p:sp>
         <p:nvSpPr>
-          <p:cNvPr id="16" name="Shape 13"/>
-          <p:cNvSpPr/>
-          <p:nvPr/>
-        </p:nvSpPr>
-        <p:spPr>
-          <a:xfrm>
-            <a:off x="725932" y="2874314"/>
-            <a:ext cx="2941828" cy="555244"/>
+          <p:cNvPr id="17" name="Shape 14"/>
+          <p:cNvSpPr/>
+          <p:nvPr/>
+        </p:nvSpPr>
+        <p:spPr>
+          <a:xfrm>
+            <a:off x="725932" y="3277548"/>
+            <a:ext cx="2941828" cy="518668"/>
           </a:xfrm>
           <a:prstGeom prst="rect">
             <a:avLst/>
@@ -3688,13 +3730,13 @@
       </p:sp>
       <p:sp>
         <p:nvSpPr>
-          <p:cNvPr id="17" name="Shape 14"/>
-          <p:cNvSpPr/>
-          <p:nvPr/>
-        </p:nvSpPr>
-        <p:spPr>
-          <a:xfrm>
-            <a:off x="850392" y="3014776"/>
+          <p:cNvPr id="18" name="Shape 15"/>
+          <p:cNvSpPr/>
+          <p:nvPr/>
+        </p:nvSpPr>
+        <p:spPr>
+          <a:xfrm>
+            <a:off x="850392" y="3399722"/>
             <a:ext cx="274320" cy="274320"/>
           </a:xfrm>
           <a:prstGeom prst="roundRect">
@@ -3715,13 +3757,13 @@
       </p:sp>
       <p:sp>
         <p:nvSpPr>
-          <p:cNvPr id="18" name="Shape 15"/>
-          <p:cNvSpPr/>
-          <p:nvPr/>
-        </p:nvSpPr>
-        <p:spPr>
-          <a:xfrm>
-            <a:off x="918972" y="3147364"/>
+          <p:cNvPr id="19" name="Shape 16"/>
+          <p:cNvSpPr/>
+          <p:nvPr/>
+        </p:nvSpPr>
+        <p:spPr>
+          <a:xfrm>
+            <a:off x="918972" y="3532310"/>
             <a:ext cx="50292" cy="64008"/>
           </a:xfrm>
           <a:prstGeom prst="line">
@@ -3738,13 +3780,13 @@
       </p:sp>
       <p:sp>
         <p:nvSpPr>
-          <p:cNvPr id="19" name="Shape 16"/>
+          <p:cNvPr id="20" name="Shape 17"/>
           <p:cNvSpPr/>
           <p:nvPr/>
         </p:nvSpPr>
         <p:spPr>
           <a:xfrm flipV="1">
-            <a:off x="969264" y="3092500"/>
+            <a:off x="969264" y="3477446"/>
             <a:ext cx="91440" cy="118872"/>
           </a:xfrm>
           <a:prstGeom prst="line">
@@ -3761,14 +3803,14 @@
       </p:sp>
       <p:sp>
         <p:nvSpPr>
-          <p:cNvPr id="20" name="Text 17"/>
-          <p:cNvSpPr/>
-          <p:nvPr/>
-        </p:nvSpPr>
-        <p:spPr>
-          <a:xfrm>
-            <a:off x="1225296" y="2861614"/>
-            <a:ext cx="2327148" cy="580644"/>
+          <p:cNvPr id="21" name="Text 18"/>
+          <p:cNvSpPr/>
+          <p:nvPr/>
+        </p:nvSpPr>
+        <p:spPr>
+          <a:xfrm>
+            <a:off x="1225296" y="3264848"/>
+            <a:ext cx="2327148" cy="544068"/>
           </a:xfrm>
           <a:prstGeom prst="rect">
             <a:avLst/>
@@ -3803,14 +3845,14 @@
       </p:sp>
       <p:sp>
         <p:nvSpPr>
-          <p:cNvPr id="21" name="Shape 18"/>
-          <p:cNvSpPr/>
-          <p:nvPr/>
-        </p:nvSpPr>
-        <p:spPr>
-          <a:xfrm>
-            <a:off x="3894328" y="2874314"/>
-            <a:ext cx="2941828" cy="555244"/>
+          <p:cNvPr id="22" name="Shape 19"/>
+          <p:cNvSpPr/>
+          <p:nvPr/>
+        </p:nvSpPr>
+        <p:spPr>
+          <a:xfrm>
+            <a:off x="3894328" y="3277548"/>
+            <a:ext cx="2941828" cy="518668"/>
           </a:xfrm>
           <a:prstGeom prst="rect">
             <a:avLst/>
@@ -3828,13 +3870,13 @@
       </p:sp>
       <p:sp>
         <p:nvSpPr>
-          <p:cNvPr id="22" name="Shape 19"/>
-          <p:cNvSpPr/>
-          <p:nvPr/>
-        </p:nvSpPr>
-        <p:spPr>
-          <a:xfrm>
-            <a:off x="4018788" y="3014776"/>
+          <p:cNvPr id="23" name="Shape 20"/>
+          <p:cNvSpPr/>
+          <p:nvPr/>
+        </p:nvSpPr>
+        <p:spPr>
+          <a:xfrm>
+            <a:off x="4018788" y="3399722"/>
             <a:ext cx="274320" cy="274320"/>
           </a:xfrm>
           <a:prstGeom prst="roundRect">
@@ -3855,13 +3897,13 @@
       </p:sp>
       <p:sp>
         <p:nvSpPr>
-          <p:cNvPr id="23" name="Shape 20"/>
-          <p:cNvSpPr/>
-          <p:nvPr/>
-        </p:nvSpPr>
-        <p:spPr>
-          <a:xfrm>
-            <a:off x="4087368" y="3147364"/>
+          <p:cNvPr id="24" name="Shape 21"/>
+          <p:cNvSpPr/>
+          <p:nvPr/>
+        </p:nvSpPr>
+        <p:spPr>
+          <a:xfrm>
+            <a:off x="4087368" y="3532310"/>
             <a:ext cx="50292" cy="64008"/>
           </a:xfrm>
           <a:prstGeom prst="line">
@@ -3878,13 +3920,13 @@
       </p:sp>
       <p:sp>
         <p:nvSpPr>
-          <p:cNvPr id="24" name="Shape 21"/>
+          <p:cNvPr id="25" name="Shape 22"/>
           <p:cNvSpPr/>
           <p:nvPr/>
         </p:nvSpPr>
         <p:spPr>
           <a:xfrm flipV="1">
-            <a:off x="4137660" y="3092500"/>
+            <a:off x="4137660" y="3477446"/>
             <a:ext cx="91440" cy="118872"/>
           </a:xfrm>
           <a:prstGeom prst="line">
@@ -3901,14 +3943,14 @@
       </p:sp>
       <p:sp>
         <p:nvSpPr>
-          <p:cNvPr id="25" name="Text 22"/>
-          <p:cNvSpPr/>
-          <p:nvPr/>
-        </p:nvSpPr>
-        <p:spPr>
-          <a:xfrm>
-            <a:off x="4393692" y="2861614"/>
-            <a:ext cx="2327148" cy="580644"/>
+          <p:cNvPr id="26" name="Text 23"/>
+          <p:cNvSpPr/>
+          <p:nvPr/>
+        </p:nvSpPr>
+        <p:spPr>
+          <a:xfrm>
+            <a:off x="4393692" y="3264848"/>
+            <a:ext cx="2327148" cy="544068"/>
           </a:xfrm>
           <a:prstGeom prst="rect">
             <a:avLst/>
@@ -3943,14 +3985,14 @@
       </p:sp>
       <p:sp>
         <p:nvSpPr>
-          <p:cNvPr id="26" name="Shape 23"/>
-          <p:cNvSpPr/>
-          <p:nvPr/>
-        </p:nvSpPr>
-        <p:spPr>
-          <a:xfrm>
-            <a:off x="725932" y="3555542"/>
-            <a:ext cx="2941828" cy="555244"/>
+          <p:cNvPr id="27" name="Shape 24"/>
+          <p:cNvSpPr/>
+          <p:nvPr/>
+        </p:nvSpPr>
+        <p:spPr>
+          <a:xfrm>
+            <a:off x="725932" y="3903912"/>
+            <a:ext cx="2941828" cy="518668"/>
           </a:xfrm>
           <a:prstGeom prst="rect">
             <a:avLst/>
@@ -3968,13 +4010,13 @@
       </p:sp>
       <p:sp>
         <p:nvSpPr>
-          <p:cNvPr id="27" name="Shape 24"/>
-          <p:cNvSpPr/>
-          <p:nvPr/>
-        </p:nvSpPr>
-        <p:spPr>
-          <a:xfrm>
-            <a:off x="850392" y="3696004"/>
+          <p:cNvPr id="28" name="Shape 25"/>
+          <p:cNvSpPr/>
+          <p:nvPr/>
+        </p:nvSpPr>
+        <p:spPr>
+          <a:xfrm>
+            <a:off x="850392" y="4026086"/>
             <a:ext cx="274320" cy="274320"/>
           </a:xfrm>
           <a:prstGeom prst="roundRect">
@@ -3995,13 +4037,13 @@
       </p:sp>
       <p:sp>
         <p:nvSpPr>
-          <p:cNvPr id="28" name="Shape 25"/>
-          <p:cNvSpPr/>
-          <p:nvPr/>
-        </p:nvSpPr>
-        <p:spPr>
-          <a:xfrm>
-            <a:off x="918972" y="3828592"/>
+          <p:cNvPr id="29" name="Shape 26"/>
+          <p:cNvSpPr/>
+          <p:nvPr/>
+        </p:nvSpPr>
+        <p:spPr>
+          <a:xfrm>
+            <a:off x="918972" y="4158674"/>
             <a:ext cx="50292" cy="64008"/>
           </a:xfrm>
           <a:prstGeom prst="line">
@@ -4018,13 +4060,13 @@
       </p:sp>
       <p:sp>
         <p:nvSpPr>
-          <p:cNvPr id="29" name="Shape 26"/>
+          <p:cNvPr id="30" name="Shape 27"/>
           <p:cNvSpPr/>
           <p:nvPr/>
         </p:nvSpPr>
         <p:spPr>
           <a:xfrm flipV="1">
-            <a:off x="969264" y="3773728"/>
+            <a:off x="969264" y="4103810"/>
             <a:ext cx="91440" cy="118872"/>
           </a:xfrm>
           <a:prstGeom prst="line">
@@ -4041,14 +4083,14 @@
       </p:sp>
       <p:sp>
         <p:nvSpPr>
-          <p:cNvPr id="30" name="Text 27"/>
-          <p:cNvSpPr/>
-          <p:nvPr/>
-        </p:nvSpPr>
-        <p:spPr>
-          <a:xfrm>
-            <a:off x="1225296" y="3542842"/>
-            <a:ext cx="2327148" cy="580644"/>
+          <p:cNvPr id="31" name="Text 28"/>
+          <p:cNvSpPr/>
+          <p:nvPr/>
+        </p:nvSpPr>
+        <p:spPr>
+          <a:xfrm>
+            <a:off x="1225296" y="3891212"/>
+            <a:ext cx="2327148" cy="544068"/>
           </a:xfrm>
           <a:prstGeom prst="rect">
             <a:avLst/>
@@ -4083,14 +4125,14 @@
       </p:sp>
       <p:sp>
         <p:nvSpPr>
-          <p:cNvPr id="31" name="Shape 28"/>
-          <p:cNvSpPr/>
-          <p:nvPr/>
-        </p:nvSpPr>
-        <p:spPr>
-          <a:xfrm>
-            <a:off x="3894328" y="3555542"/>
-            <a:ext cx="2941828" cy="555244"/>
+          <p:cNvPr id="32" name="Shape 29"/>
+          <p:cNvSpPr/>
+          <p:nvPr/>
+        </p:nvSpPr>
+        <p:spPr>
+          <a:xfrm>
+            <a:off x="3894328" y="3903912"/>
+            <a:ext cx="2941828" cy="518668"/>
           </a:xfrm>
           <a:prstGeom prst="rect">
             <a:avLst/>
@@ -4108,13 +4150,13 @@
       </p:sp>
       <p:sp>
         <p:nvSpPr>
-          <p:cNvPr id="32" name="Shape 29"/>
-          <p:cNvSpPr/>
-          <p:nvPr/>
-        </p:nvSpPr>
-        <p:spPr>
-          <a:xfrm>
-            <a:off x="4018788" y="3696004"/>
+          <p:cNvPr id="33" name="Shape 30"/>
+          <p:cNvSpPr/>
+          <p:nvPr/>
+        </p:nvSpPr>
+        <p:spPr>
+          <a:xfrm>
+            <a:off x="4018788" y="4026086"/>
             <a:ext cx="274320" cy="274320"/>
           </a:xfrm>
           <a:prstGeom prst="roundRect">
@@ -4135,13 +4177,13 @@
       </p:sp>
       <p:sp>
         <p:nvSpPr>
-          <p:cNvPr id="33" name="Shape 30"/>
-          <p:cNvSpPr/>
-          <p:nvPr/>
-        </p:nvSpPr>
-        <p:spPr>
-          <a:xfrm>
-            <a:off x="4087368" y="3828592"/>
+          <p:cNvPr id="34" name="Shape 31"/>
+          <p:cNvSpPr/>
+          <p:nvPr/>
+        </p:nvSpPr>
+        <p:spPr>
+          <a:xfrm>
+            <a:off x="4087368" y="4158674"/>
             <a:ext cx="50292" cy="64008"/>
           </a:xfrm>
           <a:prstGeom prst="line">
@@ -4158,13 +4200,13 @@
       </p:sp>
       <p:sp>
         <p:nvSpPr>
-          <p:cNvPr id="34" name="Shape 31"/>
+          <p:cNvPr id="35" name="Shape 32"/>
           <p:cNvSpPr/>
           <p:nvPr/>
         </p:nvSpPr>
         <p:spPr>
           <a:xfrm flipV="1">
-            <a:off x="4137660" y="3773728"/>
+            <a:off x="4137660" y="4103810"/>
             <a:ext cx="91440" cy="118872"/>
           </a:xfrm>
           <a:prstGeom prst="line">
@@ -4181,14 +4223,14 @@
       </p:sp>
       <p:sp>
         <p:nvSpPr>
-          <p:cNvPr id="35" name="Text 32"/>
-          <p:cNvSpPr/>
-          <p:nvPr/>
-        </p:nvSpPr>
-        <p:spPr>
-          <a:xfrm>
-            <a:off x="4393692" y="3542842"/>
-            <a:ext cx="2327148" cy="580644"/>
+          <p:cNvPr id="36" name="Text 33"/>
+          <p:cNvSpPr/>
+          <p:nvPr/>
+        </p:nvSpPr>
+        <p:spPr>
+          <a:xfrm>
+            <a:off x="4393692" y="3891212"/>
+            <a:ext cx="2327148" cy="544068"/>
           </a:xfrm>
           <a:prstGeom prst="rect">
             <a:avLst/>
@@ -4223,14 +4265,14 @@
       </p:sp>
       <p:sp>
         <p:nvSpPr>
-          <p:cNvPr id="36" name="Shape 33"/>
-          <p:cNvSpPr/>
-          <p:nvPr/>
-        </p:nvSpPr>
-        <p:spPr>
-          <a:xfrm>
-            <a:off x="725932" y="4236770"/>
-            <a:ext cx="2941828" cy="555244"/>
+          <p:cNvPr id="37" name="Shape 34"/>
+          <p:cNvSpPr/>
+          <p:nvPr/>
+        </p:nvSpPr>
+        <p:spPr>
+          <a:xfrm>
+            <a:off x="725932" y="4530276"/>
+            <a:ext cx="2941828" cy="518668"/>
           </a:xfrm>
           <a:prstGeom prst="rect">
             <a:avLst/>
@@ -4248,13 +4290,13 @@
       </p:sp>
       <p:sp>
         <p:nvSpPr>
-          <p:cNvPr id="37" name="Shape 34"/>
-          <p:cNvSpPr/>
-          <p:nvPr/>
-        </p:nvSpPr>
-        <p:spPr>
-          <a:xfrm>
-            <a:off x="850392" y="4377232"/>
+          <p:cNvPr id="38" name="Shape 35"/>
+          <p:cNvSpPr/>
+          <p:nvPr/>
+        </p:nvSpPr>
+        <p:spPr>
+          <a:xfrm>
+            <a:off x="850392" y="4652450"/>
             <a:ext cx="274320" cy="274320"/>
           </a:xfrm>
           <a:prstGeom prst="roundRect">
@@ -4275,13 +4317,13 @@
       </p:sp>
       <p:sp>
         <p:nvSpPr>
-          <p:cNvPr id="38" name="Shape 35"/>
-          <p:cNvSpPr/>
-          <p:nvPr/>
-        </p:nvSpPr>
-        <p:spPr>
-          <a:xfrm>
-            <a:off x="918972" y="4509820"/>
+          <p:cNvPr id="39" name="Shape 36"/>
+          <p:cNvSpPr/>
+          <p:nvPr/>
+        </p:nvSpPr>
+        <p:spPr>
+          <a:xfrm>
+            <a:off x="918972" y="4785038"/>
             <a:ext cx="50292" cy="64008"/>
           </a:xfrm>
           <a:prstGeom prst="line">
@@ -4298,13 +4340,13 @@
       </p:sp>
       <p:sp>
         <p:nvSpPr>
-          <p:cNvPr id="39" name="Shape 36"/>
+          <p:cNvPr id="40" name="Shape 37"/>
           <p:cNvSpPr/>
           <p:nvPr/>
         </p:nvSpPr>
         <p:spPr>
           <a:xfrm flipV="1">
-            <a:off x="969264" y="4454956"/>
+            <a:off x="969264" y="4730174"/>
             <a:ext cx="91440" cy="118872"/>
           </a:xfrm>
           <a:prstGeom prst="line">
@@ -4321,14 +4363,14 @@
       </p:sp>
       <p:sp>
         <p:nvSpPr>
-          <p:cNvPr id="40" name="Text 37"/>
-          <p:cNvSpPr/>
-          <p:nvPr/>
-        </p:nvSpPr>
-        <p:spPr>
-          <a:xfrm>
-            <a:off x="1225296" y="4224070"/>
-            <a:ext cx="2327148" cy="580644"/>
+          <p:cNvPr id="41" name="Text 38"/>
+          <p:cNvSpPr/>
+          <p:nvPr/>
+        </p:nvSpPr>
+        <p:spPr>
+          <a:xfrm>
+            <a:off x="1225296" y="4517576"/>
+            <a:ext cx="2327148" cy="544068"/>
           </a:xfrm>
           <a:prstGeom prst="rect">
             <a:avLst/>
@@ -4363,14 +4405,14 @@
       </p:sp>
       <p:sp>
         <p:nvSpPr>
-          <p:cNvPr id="41" name="Shape 38"/>
-          <p:cNvSpPr/>
-          <p:nvPr/>
-        </p:nvSpPr>
-        <p:spPr>
-          <a:xfrm>
-            <a:off x="3894328" y="4236770"/>
-            <a:ext cx="2941828" cy="555244"/>
+          <p:cNvPr id="42" name="Shape 39"/>
+          <p:cNvSpPr/>
+          <p:nvPr/>
+        </p:nvSpPr>
+        <p:spPr>
+          <a:xfrm>
+            <a:off x="3894328" y="4530276"/>
+            <a:ext cx="2941828" cy="518668"/>
           </a:xfrm>
           <a:prstGeom prst="rect">
             <a:avLst/>
@@ -4388,13 +4430,13 @@
       </p:sp>
       <p:sp>
         <p:nvSpPr>
-          <p:cNvPr id="42" name="Shape 39"/>
-          <p:cNvSpPr/>
-          <p:nvPr/>
-        </p:nvSpPr>
-        <p:spPr>
-          <a:xfrm>
-            <a:off x="4018788" y="4377232"/>
+          <p:cNvPr id="43" name="Shape 40"/>
+          <p:cNvSpPr/>
+          <p:nvPr/>
+        </p:nvSpPr>
+        <p:spPr>
+          <a:xfrm>
+            <a:off x="4018788" y="4652450"/>
             <a:ext cx="274320" cy="274320"/>
           </a:xfrm>
           <a:prstGeom prst="roundRect">
@@ -4415,13 +4457,13 @@
       </p:sp>
       <p:sp>
         <p:nvSpPr>
-          <p:cNvPr id="43" name="Shape 40"/>
-          <p:cNvSpPr/>
-          <p:nvPr/>
-        </p:nvSpPr>
-        <p:spPr>
-          <a:xfrm>
-            <a:off x="4087368" y="4509820"/>
+          <p:cNvPr id="44" name="Shape 41"/>
+          <p:cNvSpPr/>
+          <p:nvPr/>
+        </p:nvSpPr>
+        <p:spPr>
+          <a:xfrm>
+            <a:off x="4087368" y="4785038"/>
             <a:ext cx="50292" cy="64008"/>
           </a:xfrm>
           <a:prstGeom prst="line">
@@ -4438,13 +4480,13 @@
       </p:sp>
       <p:sp>
         <p:nvSpPr>
-          <p:cNvPr id="44" name="Shape 41"/>
+          <p:cNvPr id="45" name="Shape 42"/>
           <p:cNvSpPr/>
           <p:nvPr/>
         </p:nvSpPr>
         <p:spPr>
           <a:xfrm flipV="1">
-            <a:off x="4137660" y="4454956"/>
+            <a:off x="4137660" y="4730174"/>
             <a:ext cx="91440" cy="118872"/>
           </a:xfrm>
           <a:prstGeom prst="line">
@@ -4461,14 +4503,14 @@
       </p:sp>
       <p:sp>
         <p:nvSpPr>
-          <p:cNvPr id="45" name="Text 42"/>
-          <p:cNvSpPr/>
-          <p:nvPr/>
-        </p:nvSpPr>
-        <p:spPr>
-          <a:xfrm>
-            <a:off x="4393692" y="4224070"/>
-            <a:ext cx="2327148" cy="580644"/>
+          <p:cNvPr id="46" name="Text 43"/>
+          <p:cNvSpPr/>
+          <p:nvPr/>
+        </p:nvSpPr>
+        <p:spPr>
+          <a:xfrm>
+            <a:off x="4393692" y="4517576"/>
+            <a:ext cx="2327148" cy="544068"/>
           </a:xfrm>
           <a:prstGeom prst="rect">
             <a:avLst/>
@@ -4503,13 +4545,13 @@
       </p:sp>
       <p:sp>
         <p:nvSpPr>
-          <p:cNvPr id="46" name="Shape 43"/>
-          <p:cNvSpPr/>
-          <p:nvPr/>
-        </p:nvSpPr>
-        <p:spPr>
-          <a:xfrm>
-            <a:off x="713232" y="5125384"/>
+          <p:cNvPr id="47" name="Shape 44"/>
+          <p:cNvSpPr/>
+          <p:nvPr/>
+        </p:nvSpPr>
+        <p:spPr>
+          <a:xfrm>
+            <a:off x="713232" y="5322419"/>
             <a:ext cx="6135624" cy="983587"/>
           </a:xfrm>
           <a:prstGeom prst="roundRect">
@@ -4525,13 +4567,13 @@
       </p:sp>
       <p:sp>
         <p:nvSpPr>
-          <p:cNvPr id="47" name="Text 44"/>
-          <p:cNvSpPr/>
-          <p:nvPr/>
-        </p:nvSpPr>
-        <p:spPr>
-          <a:xfrm>
-            <a:off x="1042416" y="5125384"/>
+          <p:cNvPr id="48" name="Text 45"/>
+          <p:cNvSpPr/>
+          <p:nvPr/>
+        </p:nvSpPr>
+        <p:spPr>
+          <a:xfrm>
+            <a:off x="1042416" y="5322419"/>
             <a:ext cx="5477256" cy="983587"/>
           </a:xfrm>
           <a:prstGeom prst="rect">
@@ -4587,13 +4629,13 @@
       </p:sp>
       <p:sp>
         <p:nvSpPr>
-          <p:cNvPr id="48" name="Shape 45"/>
+          <p:cNvPr id="49" name="Shape 46"/>
           <p:cNvSpPr/>
           <p:nvPr/>
         </p:nvSpPr>
         <p:spPr>
           <a:xfrm rot="10800000">
-            <a:off x="6245352" y="6099828"/>
+            <a:off x="6245352" y="6296862"/>
             <a:ext cx="237744" cy="182880"/>
           </a:xfrm>
           <a:prstGeom prst="triangle">
@@ -4607,13 +4649,13 @@
       </p:sp>
       <p:sp>
         <p:nvSpPr>
-          <p:cNvPr id="49" name="Text 46"/>
-          <p:cNvSpPr/>
-          <p:nvPr/>
-        </p:nvSpPr>
-        <p:spPr>
-          <a:xfrm>
-            <a:off x="713232" y="6449684"/>
+          <p:cNvPr id="50" name="Text 47"/>
+          <p:cNvSpPr/>
+          <p:nvPr/>
+        </p:nvSpPr>
+        <p:spPr>
+          <a:xfrm>
+            <a:off x="713232" y="6585409"/>
             <a:ext cx="6135624" cy="702713"/>
           </a:xfrm>
           <a:prstGeom prst="rect">
@@ -4649,13 +4691,13 @@
       </p:sp>
       <p:sp>
         <p:nvSpPr>
-          <p:cNvPr id="50" name="Text 47"/>
-          <p:cNvSpPr/>
-          <p:nvPr/>
-        </p:nvSpPr>
-        <p:spPr>
-          <a:xfrm>
-            <a:off x="713232" y="7277911"/>
+          <p:cNvPr id="51" name="Text 48"/>
+          <p:cNvSpPr/>
+          <p:nvPr/>
+        </p:nvSpPr>
+        <p:spPr>
+          <a:xfrm>
+            <a:off x="713232" y="7382272"/>
             <a:ext cx="6135624" cy="270814"/>
           </a:xfrm>
           <a:prstGeom prst="rect">
@@ -4691,13 +4733,13 @@
       </p:sp>
       <p:sp>
         <p:nvSpPr>
-          <p:cNvPr id="51" name="Text 48"/>
-          <p:cNvSpPr/>
-          <p:nvPr/>
-        </p:nvSpPr>
-        <p:spPr>
-          <a:xfrm>
-            <a:off x="713232" y="7674238"/>
+          <p:cNvPr id="52" name="Text 49"/>
+          <p:cNvSpPr/>
+          <p:nvPr/>
+        </p:nvSpPr>
+        <p:spPr>
+          <a:xfrm>
+            <a:off x="713232" y="7747236"/>
             <a:ext cx="6135624" cy="702713"/>
           </a:xfrm>
           <a:prstGeom prst="rect">
@@ -4733,13 +4775,13 @@
       </p:sp>
       <p:sp>
         <p:nvSpPr>
-          <p:cNvPr id="52" name="Shape 49"/>
-          <p:cNvSpPr/>
-          <p:nvPr/>
-        </p:nvSpPr>
-        <p:spPr>
-          <a:xfrm>
-            <a:off x="713232" y="8602673"/>
+          <p:cNvPr id="53" name="Shape 50"/>
+          <p:cNvSpPr/>
+          <p:nvPr/>
+        </p:nvSpPr>
+        <p:spPr>
+          <a:xfrm>
+            <a:off x="713232" y="8618607"/>
             <a:ext cx="6135624" cy="32004"/>
           </a:xfrm>
           <a:prstGeom prst="rect">
@@ -4753,13 +4795,13 @@
       </p:sp>
       <p:sp>
         <p:nvSpPr>
-          <p:cNvPr id="53" name="Text 50"/>
-          <p:cNvSpPr/>
-          <p:nvPr/>
-        </p:nvSpPr>
-        <p:spPr>
-          <a:xfrm>
-            <a:off x="713232" y="8876993"/>
+          <p:cNvPr id="54" name="Text 51"/>
+          <p:cNvSpPr/>
+          <p:nvPr/>
+        </p:nvSpPr>
+        <p:spPr>
+          <a:xfrm>
+            <a:off x="713232" y="8892927"/>
             <a:ext cx="6135624" cy="365760"/>
           </a:xfrm>
           <a:prstGeom prst="rect">
@@ -4795,13 +4837,13 @@
       </p:sp>
       <p:sp>
         <p:nvSpPr>
-          <p:cNvPr id="54" name="Text 51"/>
-          <p:cNvSpPr/>
-          <p:nvPr/>
-        </p:nvSpPr>
-        <p:spPr>
-          <a:xfrm>
-            <a:off x="713232" y="9279329"/>
+          <p:cNvPr id="55" name="Text 52"/>
+          <p:cNvSpPr/>
+          <p:nvPr/>
+        </p:nvSpPr>
+        <p:spPr>
+          <a:xfrm>
+            <a:off x="713232" y="9295263"/>
             <a:ext cx="6135624" cy="420624"/>
           </a:xfrm>
           <a:prstGeom prst="rect">
@@ -4857,7 +4899,7 @@
       </p:sp>
       <p:sp>
         <p:nvSpPr>
-          <p:cNvPr id="55" name="Shape 52"/>
+          <p:cNvPr id="56" name="Shape 53"/>
           <p:cNvSpPr/>
           <p:nvPr/>
         </p:nvSpPr>
@@ -4877,7 +4919,7 @@
       </p:sp>
       <p:sp>
         <p:nvSpPr>
-          <p:cNvPr id="56" name="Text 53"/>
+          <p:cNvPr id="57" name="Text 54"/>
           <p:cNvSpPr/>
           <p:nvPr/>
         </p:nvSpPr>
@@ -4919,7 +4961,7 @@
       </p:sp>
       <p:sp>
         <p:nvSpPr>
-          <p:cNvPr id="57" name="Text 54"/>
+          <p:cNvPr id="58" name="Text 55"/>
           <p:cNvSpPr/>
           <p:nvPr/>
         </p:nvSpPr>

</xml_diff>